<commit_message>
Add and update files mmei 06052026
</commit_message>
<xml_diff>
--- a/Presentation2_26-02-2026.pptx
+++ b/Presentation2_26-02-2026.pptx
@@ -23598,8 +23598,8 @@
         </p:blipFill>
         <p:spPr>
           <a:xfrm>
-            <a:off x="2438195" y="1916355"/>
-            <a:ext cx="4649273" cy="2683953"/>
+            <a:off x="1494389" y="1916355"/>
+            <a:ext cx="5382929" cy="3107481"/>
           </a:xfrm>
           <a:prstGeom prst="rect">
             <a:avLst/>

</xml_diff>